<commit_message>
Pin the slide to a gothic typeface and drop the speaker notes
Puts Noto Sans JP and the platform gothic faces at the front of the font
stack so Japanese text never falls back to a serif face, and removes the
speaker notes from the PowerPoint version.

Co-Authored-By: Claude Opus 5 <noreply@anthropic.com>
Claude-Session: https://claude.ai/code/session_01JXhqmNGH8aKf77ZHb7baAU
</commit_message>
<xml_diff>
--- a/iNTYNC-app-experience.pptx
+++ b/iNTYNC-app-experience.pptx
@@ -502,11 +502,7 @@
           <a:p>
             <a:r>
               <a:rPr lang="en-US" dirty="0"/>
-              <a:t>iNTYNCのアプリ体験を3ステップで説明するスライド。
-01 レッスン前: 振り付けとポイントを事前共有。
-02 レッスン中: ついていけない箇所をその場で動画復習。
-03 レッスン後: 自宅練習と振り返りをフィードバックでつなぐ。
-各ステップの点線枠はアプリ画面や写真を入れるための余白。下部はコーチ／生徒それぞれのメリット。</a:t>
+              <a:t/>
             </a:r>
             <a:endParaRPr lang="en-US" dirty="0"/>
           </a:p>

</xml_diff>